<commit_message>
fix(utm,gui,docs): wait for DRM before display setup, pulse unknown hardware badges, drop CH test note, PPTX port 8777
</commit_message>
<xml_diff>
--- a/docs/presentations/pptx/PFSM_overview.pptx
+++ b/docs/presentations/pptx/PFSM_overview.pptx
@@ -6963,7 +6963,7 @@
                 </a:solidFill>
                 <a:latin typeface="Calibri"/>
               </a:rPr>
-              <a:t> on :8765, polled every 1–2 s.</a:t>
+              <a:t> on :8777, polled every 1–2 s.</a:t>
             </a:r>
           </a:p>
           <a:p>
@@ -35127,7 +35127,7 @@
                 </a:solidFill>
                 <a:latin typeface="Calibri"/>
               </a:rPr>
-              <a:t>— stdlib-only, port 8765.</a:t>
+              <a:t>— stdlib-only, port 8777.</a:t>
             </a:r>
           </a:p>
         </p:txBody>

</xml_diff>